<commit_message>
RSM v3 full manuscript and submission package
- Run extended IPD sensitivity (sample size, Z-to-Y, Z-to-X) and non-linearity simulations.
- Update generate_summary.py to produce rsm_ipd_sensitivity_* and rsm_ipd_nonlinearity_* summaries.
- Expand generate_ione_rsm_v3.py with new Results subsections, Tables 4-7 and Figures 4-5.
- Fix best-method diagnostic reporting and data-consistent sensitivity/nonlinearity prose.
- Add generate_rsm_tables.py separate tables docx and md_to_rsm_docx math handling.
- Update README.md reproduction instructions for RSM.
- Build IONE_rsm_v3.docx, title page, cover letter, figures, pptx and zip package.

Co-Authored-By: Tatsuki Onishi <bougtoir@gmail.com>
</commit_message>
<xml_diff>
--- a/results/figures/pptx/rsm_figures.pptx
+++ b/results/figures/pptx/rsm_figures.pptx
@@ -8,6 +8,8 @@
     <p:sldId id="256" r:id="rId7"/>
     <p:sldId id="257" r:id="rId8"/>
     <p:sldId id="258" r:id="rId9"/>
+    <p:sldId id="259" r:id="rId10"/>
+    <p:sldId id="260" r:id="rId11"/>
   </p:sldIdLst>
   <p:sldSz cx="12191695" cy="6858000" type="screen4x3"/>
   <p:notesSz cx="6858000" cy="9144000"/>
@@ -3380,6 +3382,214 @@
             </a:pPr>
             <a:r>
               <a:t>Real-data illustration: ARI by dataset and method.</a:t>
+            </a:r>
+          </a:p>
+        </p:txBody>
+      </p:sp>
+    </p:spTree>
+  </p:cSld>
+  <p:clrMapOvr>
+    <a:masterClrMapping/>
+  </p:clrMapOvr>
+</p:sld>
+</file>
+
+<file path=ppt/slides/slide4.xml><?xml version="1.0" encoding="utf-8"?>
+<p:sld xmlns:a="http://schemas.openxmlformats.org/drawingml/2006/main" xmlns:p="http://schemas.openxmlformats.org/presentationml/2006/main" xmlns:r="http://schemas.openxmlformats.org/officeDocument/2006/relationships">
+  <p:cSld>
+    <p:spTree>
+      <p:nvGrpSpPr>
+        <p:cNvPr id="1" name=""/>
+        <p:cNvGrpSpPr/>
+        <p:nvPr/>
+      </p:nvGrpSpPr>
+      <p:grpSpPr/>
+      <p:sp>
+        <p:nvSpPr>
+          <p:cNvPr id="2" name="TextBox 1"/>
+          <p:cNvSpPr txBox="1"/>
+          <p:nvPr/>
+        </p:nvSpPr>
+        <p:spPr>
+          <a:xfrm>
+            <a:off x="457200" y="274320"/>
+            <a:ext cx="10972800" cy="548640"/>
+          </a:xfrm>
+          <a:prstGeom prst="rect">
+            <a:avLst/>
+          </a:prstGeom>
+          <a:noFill/>
+        </p:spPr>
+        <p:txBody>
+          <a:bodyPr wrap="none">
+            <a:spAutoFit/>
+          </a:bodyPr>
+          <a:lstStyle/>
+          <a:p>
+            <a:pPr>
+              <a:defRPr sz="2000" b="1"/>
+            </a:pPr>
+            <a:r>
+              <a:t>Figure 4</a:t>
+            </a:r>
+          </a:p>
+        </p:txBody>
+      </p:sp>
+      <p:pic>
+        <p:nvPicPr>
+          <p:cNvPr id="3" name="Picture 2" descr="fig4_rsm_ipd_sample_size.png"/>
+          <p:cNvPicPr>
+            <a:picLocks noChangeAspect="1"/>
+          </p:cNvPicPr>
+          <p:nvPr/>
+        </p:nvPicPr>
+        <p:blipFill>
+          <a:blip r:embed="rId2"/>
+          <a:stretch>
+            <a:fillRect/>
+          </a:stretch>
+        </p:blipFill>
+        <p:spPr>
+          <a:xfrm>
+            <a:off x="914400" y="1097280"/>
+            <a:ext cx="10362895" cy="6476809"/>
+          </a:xfrm>
+          <a:prstGeom prst="rect">
+            <a:avLst/>
+          </a:prstGeom>
+        </p:spPr>
+      </p:pic>
+      <p:sp>
+        <p:nvSpPr>
+          <p:cNvPr id="4" name="TextBox 3"/>
+          <p:cNvSpPr txBox="1"/>
+          <p:nvPr/>
+        </p:nvSpPr>
+        <p:spPr>
+          <a:xfrm>
+            <a:off x="457200" y="5943600"/>
+            <a:ext cx="10972800" cy="731520"/>
+          </a:xfrm>
+          <a:prstGeom prst="rect">
+            <a:avLst/>
+          </a:prstGeom>
+          <a:noFill/>
+        </p:spPr>
+        <p:txBody>
+          <a:bodyPr wrap="none">
+            <a:spAutoFit/>
+          </a:bodyPr>
+          <a:lstStyle/>
+          <a:p>
+            <a:pPr>
+              <a:defRPr sz="1400"/>
+            </a:pPr>
+            <a:r>
+              <a:t>Sample-size sensitivity of random-effects ATE bias reduction (K=5).</a:t>
+            </a:r>
+          </a:p>
+        </p:txBody>
+      </p:sp>
+    </p:spTree>
+  </p:cSld>
+  <p:clrMapOvr>
+    <a:masterClrMapping/>
+  </p:clrMapOvr>
+</p:sld>
+</file>
+
+<file path=ppt/slides/slide5.xml><?xml version="1.0" encoding="utf-8"?>
+<p:sld xmlns:a="http://schemas.openxmlformats.org/drawingml/2006/main" xmlns:p="http://schemas.openxmlformats.org/presentationml/2006/main" xmlns:r="http://schemas.openxmlformats.org/officeDocument/2006/relationships">
+  <p:cSld>
+    <p:spTree>
+      <p:nvGrpSpPr>
+        <p:cNvPr id="1" name=""/>
+        <p:cNvGrpSpPr/>
+        <p:nvPr/>
+      </p:nvGrpSpPr>
+      <p:grpSpPr/>
+      <p:sp>
+        <p:nvSpPr>
+          <p:cNvPr id="2" name="TextBox 1"/>
+          <p:cNvSpPr txBox="1"/>
+          <p:nvPr/>
+        </p:nvSpPr>
+        <p:spPr>
+          <a:xfrm>
+            <a:off x="457200" y="274320"/>
+            <a:ext cx="10972800" cy="548640"/>
+          </a:xfrm>
+          <a:prstGeom prst="rect">
+            <a:avLst/>
+          </a:prstGeom>
+          <a:noFill/>
+        </p:spPr>
+        <p:txBody>
+          <a:bodyPr wrap="none">
+            <a:spAutoFit/>
+          </a:bodyPr>
+          <a:lstStyle/>
+          <a:p>
+            <a:pPr>
+              <a:defRPr sz="2000" b="1"/>
+            </a:pPr>
+            <a:r>
+              <a:t>Figure 5</a:t>
+            </a:r>
+          </a:p>
+        </p:txBody>
+      </p:sp>
+      <p:pic>
+        <p:nvPicPr>
+          <p:cNvPr id="3" name="Picture 2" descr="fig5_rsm_ipd_nonlinearity.png"/>
+          <p:cNvPicPr>
+            <a:picLocks noChangeAspect="1"/>
+          </p:cNvPicPr>
+          <p:nvPr/>
+        </p:nvPicPr>
+        <p:blipFill>
+          <a:blip r:embed="rId2"/>
+          <a:stretch>
+            <a:fillRect/>
+          </a:stretch>
+        </p:blipFill>
+        <p:spPr>
+          <a:xfrm>
+            <a:off x="914400" y="1097280"/>
+            <a:ext cx="10362895" cy="6476809"/>
+          </a:xfrm>
+          <a:prstGeom prst="rect">
+            <a:avLst/>
+          </a:prstGeom>
+        </p:spPr>
+      </p:pic>
+      <p:sp>
+        <p:nvSpPr>
+          <p:cNvPr id="4" name="TextBox 3"/>
+          <p:cNvSpPr txBox="1"/>
+          <p:nvPr/>
+        </p:nvSpPr>
+        <p:spPr>
+          <a:xfrm>
+            <a:off x="457200" y="5943600"/>
+            <a:ext cx="10972800" cy="731520"/>
+          </a:xfrm>
+          <a:prstGeom prst="rect">
+            <a:avLst/>
+          </a:prstGeom>
+          <a:noFill/>
+        </p:spPr>
+        <p:txBody>
+          <a:bodyPr wrap="none">
+            <a:spAutoFit/>
+          </a:bodyPr>
+          <a:lstStyle/>
+          <a:p>
+            <a:pPr>
+              <a:defRPr sz="1400"/>
+            </a:pPr>
+            <a:r>
+              <a:t>Non-linear Z-&gt;X robustness: random-effects ATE bias reduction (n=2000, K=5).</a:t>
             </a:r>
           </a:p>
         </p:txBody>

</xml_diff>

<commit_message>
Address Biostatistics reviewer perspective: split supplementary materials, expand reproducibility/AI declarations, add MCSE to sensitivity tables, generate double-spaced PDF, update cover letter
Co-Authored-By: Tatsuki Onishi <bougtoir@gmail.com>
</commit_message>
<xml_diff>
--- a/results/figures/pptx/rsm_figures.pptx
+++ b/results/figures/pptx/rsm_figures.pptx
@@ -3140,7 +3140,7 @@
         <p:spPr>
           <a:xfrm>
             <a:off x="914400" y="1097280"/>
-            <a:ext cx="10362895" cy="3985729"/>
+            <a:ext cx="10362895" cy="2914564"/>
           </a:xfrm>
           <a:prstGeom prst="rect">
             <a:avLst/>
@@ -3173,7 +3173,7 @@
               <a:defRPr sz="1400"/>
             </a:pPr>
             <a:r>
-              <a:t>Primary IPD scenario: diagnostic metrics and ATE bias reduction by method.</a:t>
+              <a:t>Primary IPD scenario: (a) ARI, (b) C1/W coherence diagnostics, and (c) ATE bias reduction by method.</a:t>
             </a:r>
           </a:p>
         </p:txBody>

</xml_diff>

<commit_message>
SMMR v1: revise target to Statistical Methods in Medical Research, implement reviewer points 10/12, add diagnostic ROC and CATE variance figure
</commit_message>
<xml_diff>
--- a/results/figures/pptx/rsm_figures.pptx
+++ b/results/figures/pptx/rsm_figures.pptx
@@ -10,6 +10,8 @@
     <p:sldId id="258" r:id="rId9"/>
     <p:sldId id="259" r:id="rId10"/>
     <p:sldId id="260" r:id="rId11"/>
+    <p:sldId id="261" r:id="rId12"/>
+    <p:sldId id="262" r:id="rId13"/>
   </p:sldIdLst>
   <p:sldSz cx="12191695" cy="6858000" type="screen4x3"/>
   <p:notesSz cx="6858000" cy="9144000"/>
@@ -3590,6 +3592,214 @@
             </a:pPr>
             <a:r>
               <a:t>Non-linear Z-&gt;X robustness: random-effects ATE bias reduction (n=2000, K=5).</a:t>
+            </a:r>
+          </a:p>
+        </p:txBody>
+      </p:sp>
+    </p:spTree>
+  </p:cSld>
+  <p:clrMapOvr>
+    <a:masterClrMapping/>
+  </p:clrMapOvr>
+</p:sld>
+</file>
+
+<file path=ppt/slides/slide6.xml><?xml version="1.0" encoding="utf-8"?>
+<p:sld xmlns:a="http://schemas.openxmlformats.org/drawingml/2006/main" xmlns:p="http://schemas.openxmlformats.org/presentationml/2006/main" xmlns:r="http://schemas.openxmlformats.org/officeDocument/2006/relationships">
+  <p:cSld>
+    <p:spTree>
+      <p:nvGrpSpPr>
+        <p:cNvPr id="1" name=""/>
+        <p:cNvGrpSpPr/>
+        <p:nvPr/>
+      </p:nvGrpSpPr>
+      <p:grpSpPr/>
+      <p:sp>
+        <p:nvSpPr>
+          <p:cNvPr id="2" name="TextBox 1"/>
+          <p:cNvSpPr txBox="1"/>
+          <p:nvPr/>
+        </p:nvSpPr>
+        <p:spPr>
+          <a:xfrm>
+            <a:off x="457200" y="274320"/>
+            <a:ext cx="10972800" cy="548640"/>
+          </a:xfrm>
+          <a:prstGeom prst="rect">
+            <a:avLst/>
+          </a:prstGeom>
+          <a:noFill/>
+        </p:spPr>
+        <p:txBody>
+          <a:bodyPr wrap="none">
+            <a:spAutoFit/>
+          </a:bodyPr>
+          <a:lstStyle/>
+          <a:p>
+            <a:pPr>
+              <a:defRPr sz="2000" b="1"/>
+            </a:pPr>
+            <a:r>
+              <a:t>Figure 6</a:t>
+            </a:r>
+          </a:p>
+        </p:txBody>
+      </p:sp>
+      <p:pic>
+        <p:nvPicPr>
+          <p:cNvPr id="3" name="Picture 2" descr="fig6_rsm_diagnostic_calibration.png"/>
+          <p:cNvPicPr>
+            <a:picLocks noChangeAspect="1"/>
+          </p:cNvPicPr>
+          <p:nvPr/>
+        </p:nvPicPr>
+        <p:blipFill>
+          <a:blip r:embed="rId2"/>
+          <a:stretch>
+            <a:fillRect/>
+          </a:stretch>
+        </p:blipFill>
+        <p:spPr>
+          <a:xfrm>
+            <a:off x="914400" y="1097280"/>
+            <a:ext cx="10362895" cy="6476809"/>
+          </a:xfrm>
+          <a:prstGeom prst="rect">
+            <a:avLst/>
+          </a:prstGeom>
+        </p:spPr>
+      </p:pic>
+      <p:sp>
+        <p:nvSpPr>
+          <p:cNvPr id="4" name="TextBox 3"/>
+          <p:cNvSpPr txBox="1"/>
+          <p:nvPr/>
+        </p:nvSpPr>
+        <p:spPr>
+          <a:xfrm>
+            <a:off x="457200" y="5943600"/>
+            <a:ext cx="10972800" cy="731520"/>
+          </a:xfrm>
+          <a:prstGeom prst="rect">
+            <a:avLst/>
+          </a:prstGeom>
+          <a:noFill/>
+        </p:spPr>
+        <p:txBody>
+          <a:bodyPr wrap="none">
+            <a:spAutoFit/>
+          </a:bodyPr>
+          <a:lstStyle/>
+          <a:p>
+            <a:pPr>
+              <a:defRPr sz="1400"/>
+            </a:pPr>
+            <a:r>
+              <a:t>Diagnostic calibration of C1 and W_est: AUC for discriminating the alternative DGM from the empirical null distribution (n=2000, K=5).</a:t>
+            </a:r>
+          </a:p>
+        </p:txBody>
+      </p:sp>
+    </p:spTree>
+  </p:cSld>
+  <p:clrMapOvr>
+    <a:masterClrMapping/>
+  </p:clrMapOvr>
+</p:sld>
+</file>
+
+<file path=ppt/slides/slide7.xml><?xml version="1.0" encoding="utf-8"?>
+<p:sld xmlns:a="http://schemas.openxmlformats.org/drawingml/2006/main" xmlns:p="http://schemas.openxmlformats.org/presentationml/2006/main" xmlns:r="http://schemas.openxmlformats.org/officeDocument/2006/relationships">
+  <p:cSld>
+    <p:spTree>
+      <p:nvGrpSpPr>
+        <p:cNvPr id="1" name=""/>
+        <p:cNvGrpSpPr/>
+        <p:nvPr/>
+      </p:nvGrpSpPr>
+      <p:grpSpPr/>
+      <p:sp>
+        <p:nvSpPr>
+          <p:cNvPr id="2" name="TextBox 1"/>
+          <p:cNvSpPr txBox="1"/>
+          <p:nvPr/>
+        </p:nvSpPr>
+        <p:spPr>
+          <a:xfrm>
+            <a:off x="457200" y="274320"/>
+            <a:ext cx="10972800" cy="548640"/>
+          </a:xfrm>
+          <a:prstGeom prst="rect">
+            <a:avLst/>
+          </a:prstGeom>
+          <a:noFill/>
+        </p:spPr>
+        <p:txBody>
+          <a:bodyPr wrap="none">
+            <a:spAutoFit/>
+          </a:bodyPr>
+          <a:lstStyle/>
+          <a:p>
+            <a:pPr>
+              <a:defRPr sz="2000" b="1"/>
+            </a:pPr>
+            <a:r>
+              <a:t>Figure 7</a:t>
+            </a:r>
+          </a:p>
+        </p:txBody>
+      </p:sp>
+      <p:pic>
+        <p:nvPicPr>
+          <p:cNvPr id="3" name="Picture 2" descr="fig7_cate_variance_explained.png"/>
+          <p:cNvPicPr>
+            <a:picLocks noChangeAspect="1"/>
+          </p:cNvPicPr>
+          <p:nvPr/>
+        </p:nvPicPr>
+        <p:blipFill>
+          <a:blip r:embed="rId2"/>
+          <a:stretch>
+            <a:fillRect/>
+          </a:stretch>
+        </p:blipFill>
+        <p:spPr>
+          <a:xfrm>
+            <a:off x="914400" y="1097280"/>
+            <a:ext cx="10362895" cy="6476809"/>
+          </a:xfrm>
+          <a:prstGeom prst="rect">
+            <a:avLst/>
+          </a:prstGeom>
+        </p:spPr>
+      </p:pic>
+      <p:sp>
+        <p:nvSpPr>
+          <p:cNvPr id="4" name="TextBox 3"/>
+          <p:cNvSpPr txBox="1"/>
+          <p:nvPr/>
+        </p:nvSpPr>
+        <p:spPr>
+          <a:xfrm>
+            <a:off x="457200" y="5943600"/>
+            <a:ext cx="10972800" cy="731520"/>
+          </a:xfrm>
+          <a:prstGeom prst="rect">
+            <a:avLst/>
+          </a:prstGeom>
+          <a:noFill/>
+        </p:spPr>
+        <p:txBody>
+          <a:bodyPr wrap="none">
+            <a:spAutoFit/>
+          </a:bodyPr>
+          <a:lstStyle/>
+          <a:p>
+            <a:pPr>
+              <a:defRPr sz="1400"/>
+            </a:pPr>
+            <a:r>
+              <a:t>CATE variance explained (eta^2 = W_true) and estimated W_est by method in the primary scenario (n=2000, K=5).</a:t>
             </a:r>
           </a:p>
         </p:txBody>

</xml_diff>